<commit_message>
bids: re-verify Cmd Post + NDI W50S7626QA001 OPEN (due 04 JUN 2026 14:00 CDT) + refresh proposal exports
Re-verification on 2026-05-28 (5 days after initial triage 2026-05-23):
- Bid window still OPEN: 7 calendar days / 5 business days remaining.
- TXANG 136th Airlift Wing (Air National Guard, NAS JRB Fort Worth), not Army.
- Section M: FAR 12.203(c)(2) comparative best-value (not LPTA).
- 100% small-business set-aside, NAICS 236220, gov target \-\.
- SF 1442 AcroForm field values now extracted via pypdf and folded into
  00-window-check.md (closing hour 02:00 PM CDT, NAICS, target price, KO,
  bonding=YES, 90-day perf, 60-day bid acceptance) — replaces prior \[VERIFY\] holes.
- All 4 proposal exports re-rendered (client exec summary, full proposal,
  internal workbook, pitch deck) with current firm profile.

Co-authored-by: Cursor <cursoragent@cursor.com>
</commit_message>
<xml_diff>
--- a/bids/cmd-post-ndi-W50S7626QA001/proposal/exports/cmd-post-ndi-W50S7626QA001-pitch-deck.pptx
+++ b/bids/cmd-post-ndi-W50S7626QA001/proposal/exports/cmd-post-ndi-W50S7626QA001-pitch-deck.pptx
@@ -3424,7 +3424,7 @@
                 </a:solidFill>
                 <a:latin typeface="Calibri"/>
               </a:rPr>
-              <a:t>Submission date __________   ·   Document prepared 2026-05-23</a:t>
+              <a:t>Submission date __________   ·   Document prepared 2026-05-28</a:t>
             </a:r>
           </a:p>
         </p:txBody>
@@ -4890,7 +4890,7 @@
                 </a:solidFill>
                 <a:latin typeface="Calibri"/>
               </a:rPr>
-              <a:t>Bid cmd-post-ndi-W50S7626QA001   ·   2026-05-23</a:t>
+              <a:t>Bid cmd-post-ndi-W50S7626QA001   ·   2026-05-28</a:t>
             </a:r>
           </a:p>
         </p:txBody>

</xml_diff>